<commit_message>
Redesign website: updated homepage, navbar, background, active indicators, and favicons
</commit_message>
<xml_diff>
--- a/sketchbook.pptx
+++ b/sketchbook.pptx
@@ -202,7 +202,7 @@
           <a:p>
             <a:fld id="{78BC9FBE-186D-8649-8440-9BB8EFAAB974}" type="datetimeFigureOut">
               <a:rPr lang="en-US" smtClean="0"/>
-              <a:t>12/29/24</a:t>
+              <a:t>9/30/26</a:t>
             </a:fld>
             <a:endParaRPr lang="en-US"/>
           </a:p>
@@ -928,7 +928,7 @@
           <a:p>
             <a:fld id="{2AC07F00-DFFC-2947-9DAE-3128AA91D5FC}" type="datetimeFigureOut">
               <a:rPr lang="en-US" smtClean="0"/>
-              <a:t>12/29/24</a:t>
+              <a:t>9/30/26</a:t>
             </a:fld>
             <a:endParaRPr lang="en-US"/>
           </a:p>
@@ -1126,7 +1126,7 @@
           <a:p>
             <a:fld id="{2AC07F00-DFFC-2947-9DAE-3128AA91D5FC}" type="datetimeFigureOut">
               <a:rPr lang="en-US" smtClean="0"/>
-              <a:t>12/29/24</a:t>
+              <a:t>9/30/26</a:t>
             </a:fld>
             <a:endParaRPr lang="en-US"/>
           </a:p>
@@ -1334,7 +1334,7 @@
           <a:p>
             <a:fld id="{2AC07F00-DFFC-2947-9DAE-3128AA91D5FC}" type="datetimeFigureOut">
               <a:rPr lang="en-US" smtClean="0"/>
-              <a:t>12/29/24</a:t>
+              <a:t>9/30/26</a:t>
             </a:fld>
             <a:endParaRPr lang="en-US"/>
           </a:p>
@@ -1532,7 +1532,7 @@
           <a:p>
             <a:fld id="{2AC07F00-DFFC-2947-9DAE-3128AA91D5FC}" type="datetimeFigureOut">
               <a:rPr lang="en-US" smtClean="0"/>
-              <a:t>12/29/24</a:t>
+              <a:t>9/30/26</a:t>
             </a:fld>
             <a:endParaRPr lang="en-US"/>
           </a:p>
@@ -1807,7 +1807,7 @@
           <a:p>
             <a:fld id="{2AC07F00-DFFC-2947-9DAE-3128AA91D5FC}" type="datetimeFigureOut">
               <a:rPr lang="en-US" smtClean="0"/>
-              <a:t>12/29/24</a:t>
+              <a:t>9/30/26</a:t>
             </a:fld>
             <a:endParaRPr lang="en-US"/>
           </a:p>
@@ -2072,7 +2072,7 @@
           <a:p>
             <a:fld id="{2AC07F00-DFFC-2947-9DAE-3128AA91D5FC}" type="datetimeFigureOut">
               <a:rPr lang="en-US" smtClean="0"/>
-              <a:t>12/29/24</a:t>
+              <a:t>9/30/26</a:t>
             </a:fld>
             <a:endParaRPr lang="en-US"/>
           </a:p>
@@ -2484,7 +2484,7 @@
           <a:p>
             <a:fld id="{2AC07F00-DFFC-2947-9DAE-3128AA91D5FC}" type="datetimeFigureOut">
               <a:rPr lang="en-US" smtClean="0"/>
-              <a:t>12/29/24</a:t>
+              <a:t>9/30/26</a:t>
             </a:fld>
             <a:endParaRPr lang="en-US"/>
           </a:p>
@@ -2625,7 +2625,7 @@
           <a:p>
             <a:fld id="{2AC07F00-DFFC-2947-9DAE-3128AA91D5FC}" type="datetimeFigureOut">
               <a:rPr lang="en-US" smtClean="0"/>
-              <a:t>12/29/24</a:t>
+              <a:t>9/30/26</a:t>
             </a:fld>
             <a:endParaRPr lang="en-US"/>
           </a:p>
@@ -2738,7 +2738,7 @@
           <a:p>
             <a:fld id="{2AC07F00-DFFC-2947-9DAE-3128AA91D5FC}" type="datetimeFigureOut">
               <a:rPr lang="en-US" smtClean="0"/>
-              <a:t>12/29/24</a:t>
+              <a:t>9/30/26</a:t>
             </a:fld>
             <a:endParaRPr lang="en-US"/>
           </a:p>
@@ -3049,7 +3049,7 @@
           <a:p>
             <a:fld id="{2AC07F00-DFFC-2947-9DAE-3128AA91D5FC}" type="datetimeFigureOut">
               <a:rPr lang="en-US" smtClean="0"/>
-              <a:t>12/29/24</a:t>
+              <a:t>9/30/26</a:t>
             </a:fld>
             <a:endParaRPr lang="en-US"/>
           </a:p>
@@ -3337,7 +3337,7 @@
           <a:p>
             <a:fld id="{2AC07F00-DFFC-2947-9DAE-3128AA91D5FC}" type="datetimeFigureOut">
               <a:rPr lang="en-US" smtClean="0"/>
-              <a:t>12/29/24</a:t>
+              <a:t>9/30/26</a:t>
             </a:fld>
             <a:endParaRPr lang="en-US"/>
           </a:p>
@@ -3578,7 +3578,7 @@
           <a:p>
             <a:fld id="{2AC07F00-DFFC-2947-9DAE-3128AA91D5FC}" type="datetimeFigureOut">
               <a:rPr lang="en-US" smtClean="0"/>
-              <a:t>12/29/24</a:t>
+              <a:t>9/30/26</a:t>
             </a:fld>
             <a:endParaRPr lang="en-US"/>
           </a:p>
@@ -6380,53 +6380,152 @@
           <a:chExt cx="0" cy="0"/>
         </a:xfrm>
       </p:grpSpPr>
-      <p:sp>
-        <p:nvSpPr>
-          <p:cNvPr id="2" name="Title 1">
-            <a:extLst>
-              <a:ext uri="{FF2B5EF4-FFF2-40B4-BE49-F238E27FC236}">
-                <a16:creationId xmlns:a16="http://schemas.microsoft.com/office/drawing/2014/main" id="{22A045B6-54AD-5890-7CB2-FBC8A4945266}"/>
-              </a:ext>
-            </a:extLst>
-          </p:cNvPr>
-          <p:cNvSpPr>
-            <a:spLocks noGrp="1"/>
-          </p:cNvSpPr>
-          <p:nvPr>
-            <p:ph type="title"/>
-          </p:nvPr>
-        </p:nvSpPr>
-        <p:spPr/>
-        <p:txBody>
-          <a:bodyPr/>
+      <p:grpSp>
+        <p:nvGrpSpPr>
+          <p:cNvPr id="4" name="Group 3">
+            <a:extLst>
+              <a:ext uri="{FF2B5EF4-FFF2-40B4-BE49-F238E27FC236}">
+                <a16:creationId xmlns:a16="http://schemas.microsoft.com/office/drawing/2014/main" id="{28AFF962-812A-A234-A88E-EDAAC92E40D1}"/>
+              </a:ext>
+            </a:extLst>
+          </p:cNvPr>
+          <p:cNvGrpSpPr/>
+          <p:nvPr/>
+        </p:nvGrpSpPr>
+        <p:grpSpPr>
+          <a:xfrm>
+            <a:off x="687096" y="0"/>
+            <a:ext cx="2843791" cy="3962690"/>
+            <a:chOff x="2994301" y="469835"/>
+            <a:chExt cx="2843791" cy="3962690"/>
+          </a:xfrm>
+        </p:grpSpPr>
+        <p:sp>
+          <p:nvSpPr>
+            <p:cNvPr id="5" name="TextBox 4">
+              <a:extLst>
+                <a:ext uri="{FF2B5EF4-FFF2-40B4-BE49-F238E27FC236}">
+                  <a16:creationId xmlns:a16="http://schemas.microsoft.com/office/drawing/2014/main" id="{FB0EE3D1-1DF9-6E5E-A1D1-D2C97AE4A2A5}"/>
+                </a:ext>
+              </a:extLst>
+            </p:cNvPr>
+            <p:cNvSpPr txBox="1"/>
+            <p:nvPr/>
+          </p:nvSpPr>
+          <p:spPr>
+            <a:xfrm>
+              <a:off x="2994301" y="469835"/>
+              <a:ext cx="2613480" cy="3154710"/>
+            </a:xfrm>
+            <a:prstGeom prst="rect">
+              <a:avLst/>
+            </a:prstGeom>
+            <a:noFill/>
+          </p:spPr>
+          <p:txBody>
+            <a:bodyPr wrap="square" rtlCol="0">
+              <a:spAutoFit/>
+            </a:bodyPr>
+            <a:lstStyle/>
+            <a:p>
+              <a:r>
+                <a:rPr lang="en-US" sz="20000" b="1" dirty="0">
+                  <a:solidFill>
+                    <a:srgbClr val="E2208B"/>
+                  </a:solidFill>
+                  <a:latin typeface="Baguet Script" panose="020F0502020204030204" pitchFamily="34" charset="0"/>
+                  <a:cs typeface="Baguet Script" panose="020F0502020204030204" pitchFamily="34" charset="0"/>
+                </a:rPr>
+                <a:t>M</a:t>
+              </a:r>
+            </a:p>
+          </p:txBody>
+        </p:sp>
+        <p:sp>
+          <p:nvSpPr>
+            <p:cNvPr id="6" name="TextBox 5">
+              <a:extLst>
+                <a:ext uri="{FF2B5EF4-FFF2-40B4-BE49-F238E27FC236}">
+                  <a16:creationId xmlns:a16="http://schemas.microsoft.com/office/drawing/2014/main" id="{4F62D98E-AF06-9A1E-E663-5915DB279657}"/>
+                </a:ext>
+              </a:extLst>
+            </p:cNvPr>
+            <p:cNvSpPr txBox="1"/>
+            <p:nvPr/>
+          </p:nvSpPr>
+          <p:spPr>
+            <a:xfrm>
+              <a:off x="4389119" y="1277815"/>
+              <a:ext cx="1448973" cy="3154710"/>
+            </a:xfrm>
+            <a:prstGeom prst="rect">
+              <a:avLst/>
+            </a:prstGeom>
+            <a:noFill/>
+          </p:spPr>
+          <p:txBody>
+            <a:bodyPr wrap="square" rtlCol="0">
+              <a:spAutoFit/>
+            </a:bodyPr>
+            <a:lstStyle/>
+            <a:p>
+              <a:r>
+                <a:rPr lang="en-US" sz="20000" b="1" dirty="0">
+                  <a:solidFill>
+                    <a:srgbClr val="E2208B"/>
+                  </a:solidFill>
+                  <a:latin typeface="Baguet Script" panose="020F0502020204030204" pitchFamily="34" charset="0"/>
+                  <a:cs typeface="Baguet Script" panose="020F0502020204030204" pitchFamily="34" charset="0"/>
+                </a:rPr>
+                <a:t>B</a:t>
+              </a:r>
+            </a:p>
+          </p:txBody>
+        </p:sp>
+      </p:grpSp>
+      <p:sp>
+        <p:nvSpPr>
+          <p:cNvPr id="7" name="TextBox 6">
+            <a:extLst>
+              <a:ext uri="{FF2B5EF4-FFF2-40B4-BE49-F238E27FC236}">
+                <a16:creationId xmlns:a16="http://schemas.microsoft.com/office/drawing/2014/main" id="{DC49ED01-949D-F69D-0E5A-AFE598A446A1}"/>
+              </a:ext>
+            </a:extLst>
+          </p:cNvPr>
+          <p:cNvSpPr txBox="1"/>
+          <p:nvPr/>
+        </p:nvSpPr>
+        <p:spPr>
+          <a:xfrm rot="3000077">
+            <a:off x="2381780" y="1208691"/>
+            <a:ext cx="1920240" cy="1920240"/>
+          </a:xfrm>
+          <a:prstGeom prst="rect">
+            <a:avLst/>
+          </a:prstGeom>
+          <a:noFill/>
+        </p:spPr>
+        <p:txBody>
+          <a:bodyPr wrap="square" tIns="91440" bIns="91440">
+            <a:prstTxWarp prst="textCircle">
+              <a:avLst>
+                <a:gd name="adj" fmla="val 11095199"/>
+              </a:avLst>
+            </a:prstTxWarp>
+            <a:spAutoFit/>
+          </a:bodyPr>
           <a:lstStyle/>
           <a:p>
-            <a:endParaRPr lang="en-US"/>
-          </a:p>
-        </p:txBody>
-      </p:sp>
-      <p:sp>
-        <p:nvSpPr>
-          <p:cNvPr id="3" name="Content Placeholder 2">
-            <a:extLst>
-              <a:ext uri="{FF2B5EF4-FFF2-40B4-BE49-F238E27FC236}">
-                <a16:creationId xmlns:a16="http://schemas.microsoft.com/office/drawing/2014/main" id="{FA1A632F-00B7-3F41-6B31-759FD40CEB05}"/>
-              </a:ext>
-            </a:extLst>
-          </p:cNvPr>
-          <p:cNvSpPr>
-            <a:spLocks noGrp="1"/>
-          </p:cNvSpPr>
-          <p:nvPr>
-            <p:ph idx="1"/>
-          </p:nvPr>
-        </p:nvSpPr>
-        <p:spPr/>
-        <p:txBody>
-          <a:bodyPr/>
-          <a:lstStyle/>
-          <a:p>
-            <a:endParaRPr lang="en-US"/>
+            <a:r>
+              <a:rPr lang="en-US" sz="4000" dirty="0">
+                <a:solidFill>
+                  <a:srgbClr val="E2208B"/>
+                </a:solidFill>
+                <a:latin typeface="Baguet Script" panose="020F0502020204030204" pitchFamily="34" charset="0"/>
+                <a:cs typeface="Baguet Script" panose="020F0502020204030204" pitchFamily="34" charset="0"/>
+              </a:rPr>
+              <a:t>Marilyn Braojos</a:t>
+            </a:r>
           </a:p>
         </p:txBody>
       </p:sp>

</xml_diff>